<commit_message>
archive: strip local file paths from the Sprint 4 slide deck metadata
</commit_message>
<xml_diff>
--- a/SPRINT4_Slides.pptx
+++ b/SPRINT4_Slides.pptx
@@ -2581,7 +2581,7 @@
       </p:grpSpPr>
       <p:pic>
         <p:nvPicPr>
-          <p:cNvPr id="2" name="Image 0" descr="/private/tmp/claude-501/-Users-mushfiqurrahman-Library-Application-Support-Claude-scratch-workspaces-65a65a84-ad6b-4d3a-88a0-2621358d7689-499be8aa-3403-4123-8eac-18d254b7aa0a-scratch-2026-09-13-7b3d38/ef9f7b88-fe32-4abb-840c-9986bd52b9c4/scratchpad/deck/out/slides/slide-01.png">    </p:cNvPr>
+          <p:cNvPr id="2" name="Image 0">    </p:cNvPr>
           <p:cNvPicPr>
             <a:picLocks noChangeAspect="1"/>
           </p:cNvPicPr>
@@ -2630,7 +2630,7 @@
       </p:grpSpPr>
       <p:pic>
         <p:nvPicPr>
-          <p:cNvPr id="2" name="Image 0" descr="/private/tmp/claude-501/-Users-mushfiqurrahman-Library-Application-Support-Claude-scratch-workspaces-65a65a84-ad6b-4d3a-88a0-2621358d7689-499be8aa-3403-4123-8eac-18d254b7aa0a-scratch-2026-09-13-7b3d38/ef9f7b88-fe32-4abb-840c-9986bd52b9c4/scratchpad/deck/out/slides/slide-10.png">    </p:cNvPr>
+          <p:cNvPr id="2" name="Image 0">    </p:cNvPr>
           <p:cNvPicPr>
             <a:picLocks noChangeAspect="1"/>
           </p:cNvPicPr>
@@ -2679,7 +2679,7 @@
       </p:grpSpPr>
       <p:pic>
         <p:nvPicPr>
-          <p:cNvPr id="2" name="Image 0" descr="/private/tmp/claude-501/-Users-mushfiqurrahman-Library-Application-Support-Claude-scratch-workspaces-65a65a84-ad6b-4d3a-88a0-2621358d7689-499be8aa-3403-4123-8eac-18d254b7aa0a-scratch-2026-09-13-7b3d38/ef9f7b88-fe32-4abb-840c-9986bd52b9c4/scratchpad/deck/out/slides/slide-11.png">    </p:cNvPr>
+          <p:cNvPr id="2" name="Image 0">    </p:cNvPr>
           <p:cNvPicPr>
             <a:picLocks noChangeAspect="1"/>
           </p:cNvPicPr>
@@ -2728,7 +2728,7 @@
       </p:grpSpPr>
       <p:pic>
         <p:nvPicPr>
-          <p:cNvPr id="2" name="Image 0" descr="/private/tmp/claude-501/-Users-mushfiqurrahman-Library-Application-Support-Claude-scratch-workspaces-65a65a84-ad6b-4d3a-88a0-2621358d7689-499be8aa-3403-4123-8eac-18d254b7aa0a-scratch-2026-09-13-7b3d38/ef9f7b88-fe32-4abb-840c-9986bd52b9c4/scratchpad/deck/out/slides/slide-12.png">    </p:cNvPr>
+          <p:cNvPr id="2" name="Image 0">    </p:cNvPr>
           <p:cNvPicPr>
             <a:picLocks noChangeAspect="1"/>
           </p:cNvPicPr>
@@ -2777,7 +2777,7 @@
       </p:grpSpPr>
       <p:pic>
         <p:nvPicPr>
-          <p:cNvPr id="2" name="Image 0" descr="/private/tmp/claude-501/-Users-mushfiqurrahman-Library-Application-Support-Claude-scratch-workspaces-65a65a84-ad6b-4d3a-88a0-2621358d7689-499be8aa-3403-4123-8eac-18d254b7aa0a-scratch-2026-09-13-7b3d38/ef9f7b88-fe32-4abb-840c-9986bd52b9c4/scratchpad/deck/out/slides/slide-13.png">    </p:cNvPr>
+          <p:cNvPr id="2" name="Image 0">    </p:cNvPr>
           <p:cNvPicPr>
             <a:picLocks noChangeAspect="1"/>
           </p:cNvPicPr>
@@ -2826,7 +2826,7 @@
       </p:grpSpPr>
       <p:pic>
         <p:nvPicPr>
-          <p:cNvPr id="2" name="Image 0" descr="/private/tmp/claude-501/-Users-mushfiqurrahman-Library-Application-Support-Claude-scratch-workspaces-65a65a84-ad6b-4d3a-88a0-2621358d7689-499be8aa-3403-4123-8eac-18d254b7aa0a-scratch-2026-09-13-7b3d38/ef9f7b88-fe32-4abb-840c-9986bd52b9c4/scratchpad/deck/out/slides/slide-14.png">    </p:cNvPr>
+          <p:cNvPr id="2" name="Image 0">    </p:cNvPr>
           <p:cNvPicPr>
             <a:picLocks noChangeAspect="1"/>
           </p:cNvPicPr>
@@ -2875,7 +2875,7 @@
       </p:grpSpPr>
       <p:pic>
         <p:nvPicPr>
-          <p:cNvPr id="2" name="Image 0" descr="/private/tmp/claude-501/-Users-mushfiqurrahman-Library-Application-Support-Claude-scratch-workspaces-65a65a84-ad6b-4d3a-88a0-2621358d7689-499be8aa-3403-4123-8eac-18d254b7aa0a-scratch-2026-09-13-7b3d38/ef9f7b88-fe32-4abb-840c-9986bd52b9c4/scratchpad/deck/out/slides/slide-15.png">    </p:cNvPr>
+          <p:cNvPr id="2" name="Image 0">    </p:cNvPr>
           <p:cNvPicPr>
             <a:picLocks noChangeAspect="1"/>
           </p:cNvPicPr>
@@ -2924,7 +2924,7 @@
       </p:grpSpPr>
       <p:pic>
         <p:nvPicPr>
-          <p:cNvPr id="2" name="Image 0" descr="/private/tmp/claude-501/-Users-mushfiqurrahman-Library-Application-Support-Claude-scratch-workspaces-65a65a84-ad6b-4d3a-88a0-2621358d7689-499be8aa-3403-4123-8eac-18d254b7aa0a-scratch-2026-09-13-7b3d38/ef9f7b88-fe32-4abb-840c-9986bd52b9c4/scratchpad/deck/out/slides/slide-16.png">    </p:cNvPr>
+          <p:cNvPr id="2" name="Image 0">    </p:cNvPr>
           <p:cNvPicPr>
             <a:picLocks noChangeAspect="1"/>
           </p:cNvPicPr>
@@ -2973,7 +2973,7 @@
       </p:grpSpPr>
       <p:pic>
         <p:nvPicPr>
-          <p:cNvPr id="2" name="Image 0" descr="/private/tmp/claude-501/-Users-mushfiqurrahman-Library-Application-Support-Claude-scratch-workspaces-65a65a84-ad6b-4d3a-88a0-2621358d7689-499be8aa-3403-4123-8eac-18d254b7aa0a-scratch-2026-09-13-7b3d38/ef9f7b88-fe32-4abb-840c-9986bd52b9c4/scratchpad/deck/out/slides/slide-17.png">    </p:cNvPr>
+          <p:cNvPr id="2" name="Image 0">    </p:cNvPr>
           <p:cNvPicPr>
             <a:picLocks noChangeAspect="1"/>
           </p:cNvPicPr>
@@ -3022,7 +3022,7 @@
       </p:grpSpPr>
       <p:pic>
         <p:nvPicPr>
-          <p:cNvPr id="2" name="Image 0" descr="/private/tmp/claude-501/-Users-mushfiqurrahman-Library-Application-Support-Claude-scratch-workspaces-65a65a84-ad6b-4d3a-88a0-2621358d7689-499be8aa-3403-4123-8eac-18d254b7aa0a-scratch-2026-09-13-7b3d38/ef9f7b88-fe32-4abb-840c-9986bd52b9c4/scratchpad/deck/out/slides/slide-18.png">    </p:cNvPr>
+          <p:cNvPr id="2" name="Image 0">    </p:cNvPr>
           <p:cNvPicPr>
             <a:picLocks noChangeAspect="1"/>
           </p:cNvPicPr>
@@ -3071,7 +3071,7 @@
       </p:grpSpPr>
       <p:pic>
         <p:nvPicPr>
-          <p:cNvPr id="2" name="Image 0" descr="/private/tmp/claude-501/-Users-mushfiqurrahman-Library-Application-Support-Claude-scratch-workspaces-65a65a84-ad6b-4d3a-88a0-2621358d7689-499be8aa-3403-4123-8eac-18d254b7aa0a-scratch-2026-09-13-7b3d38/ef9f7b88-fe32-4abb-840c-9986bd52b9c4/scratchpad/deck/out/slides/slide-19.png">    </p:cNvPr>
+          <p:cNvPr id="2" name="Image 0">    </p:cNvPr>
           <p:cNvPicPr>
             <a:picLocks noChangeAspect="1"/>
           </p:cNvPicPr>
@@ -3120,7 +3120,7 @@
       </p:grpSpPr>
       <p:pic>
         <p:nvPicPr>
-          <p:cNvPr id="2" name="Image 0" descr="/private/tmp/claude-501/-Users-mushfiqurrahman-Library-Application-Support-Claude-scratch-workspaces-65a65a84-ad6b-4d3a-88a0-2621358d7689-499be8aa-3403-4123-8eac-18d254b7aa0a-scratch-2026-09-13-7b3d38/ef9f7b88-fe32-4abb-840c-9986bd52b9c4/scratchpad/deck/out/slides/slide-02.png">    </p:cNvPr>
+          <p:cNvPr id="2" name="Image 0">    </p:cNvPr>
           <p:cNvPicPr>
             <a:picLocks noChangeAspect="1"/>
           </p:cNvPicPr>
@@ -3169,7 +3169,7 @@
       </p:grpSpPr>
       <p:pic>
         <p:nvPicPr>
-          <p:cNvPr id="2" name="Image 0" descr="/private/tmp/claude-501/-Users-mushfiqurrahman-Library-Application-Support-Claude-scratch-workspaces-65a65a84-ad6b-4d3a-88a0-2621358d7689-499be8aa-3403-4123-8eac-18d254b7aa0a-scratch-2026-09-13-7b3d38/ef9f7b88-fe32-4abb-840c-9986bd52b9c4/scratchpad/deck/out/slides/slide-20.png">    </p:cNvPr>
+          <p:cNvPr id="2" name="Image 0">    </p:cNvPr>
           <p:cNvPicPr>
             <a:picLocks noChangeAspect="1"/>
           </p:cNvPicPr>
@@ -3218,7 +3218,7 @@
       </p:grpSpPr>
       <p:pic>
         <p:nvPicPr>
-          <p:cNvPr id="2" name="Image 0" descr="/private/tmp/claude-501/-Users-mushfiqurrahman-Library-Application-Support-Claude-scratch-workspaces-65a65a84-ad6b-4d3a-88a0-2621358d7689-499be8aa-3403-4123-8eac-18d254b7aa0a-scratch-2026-09-13-7b3d38/ef9f7b88-fe32-4abb-840c-9986bd52b9c4/scratchpad/deck/out/slides/slide-03.png">    </p:cNvPr>
+          <p:cNvPr id="2" name="Image 0">    </p:cNvPr>
           <p:cNvPicPr>
             <a:picLocks noChangeAspect="1"/>
           </p:cNvPicPr>
@@ -3267,7 +3267,7 @@
       </p:grpSpPr>
       <p:pic>
         <p:nvPicPr>
-          <p:cNvPr id="2" name="Image 0" descr="/private/tmp/claude-501/-Users-mushfiqurrahman-Library-Application-Support-Claude-scratch-workspaces-65a65a84-ad6b-4d3a-88a0-2621358d7689-499be8aa-3403-4123-8eac-18d254b7aa0a-scratch-2026-09-13-7b3d38/ef9f7b88-fe32-4abb-840c-9986bd52b9c4/scratchpad/deck/out/slides/slide-04.png">    </p:cNvPr>
+          <p:cNvPr id="2" name="Image 0">    </p:cNvPr>
           <p:cNvPicPr>
             <a:picLocks noChangeAspect="1"/>
           </p:cNvPicPr>
@@ -3316,7 +3316,7 @@
       </p:grpSpPr>
       <p:pic>
         <p:nvPicPr>
-          <p:cNvPr id="2" name="Image 0" descr="/private/tmp/claude-501/-Users-mushfiqurrahman-Library-Application-Support-Claude-scratch-workspaces-65a65a84-ad6b-4d3a-88a0-2621358d7689-499be8aa-3403-4123-8eac-18d254b7aa0a-scratch-2026-09-13-7b3d38/ef9f7b88-fe32-4abb-840c-9986bd52b9c4/scratchpad/deck/out/slides/slide-05.png">    </p:cNvPr>
+          <p:cNvPr id="2" name="Image 0">    </p:cNvPr>
           <p:cNvPicPr>
             <a:picLocks noChangeAspect="1"/>
           </p:cNvPicPr>
@@ -3365,7 +3365,7 @@
       </p:grpSpPr>
       <p:pic>
         <p:nvPicPr>
-          <p:cNvPr id="2" name="Image 0" descr="/private/tmp/claude-501/-Users-mushfiqurrahman-Library-Application-Support-Claude-scratch-workspaces-65a65a84-ad6b-4d3a-88a0-2621358d7689-499be8aa-3403-4123-8eac-18d254b7aa0a-scratch-2026-09-13-7b3d38/ef9f7b88-fe32-4abb-840c-9986bd52b9c4/scratchpad/deck/out/slides/slide-06.png">    </p:cNvPr>
+          <p:cNvPr id="2" name="Image 0">    </p:cNvPr>
           <p:cNvPicPr>
             <a:picLocks noChangeAspect="1"/>
           </p:cNvPicPr>
@@ -3414,7 +3414,7 @@
       </p:grpSpPr>
       <p:pic>
         <p:nvPicPr>
-          <p:cNvPr id="2" name="Image 0" descr="/private/tmp/claude-501/-Users-mushfiqurrahman-Library-Application-Support-Claude-scratch-workspaces-65a65a84-ad6b-4d3a-88a0-2621358d7689-499be8aa-3403-4123-8eac-18d254b7aa0a-scratch-2026-09-13-7b3d38/ef9f7b88-fe32-4abb-840c-9986bd52b9c4/scratchpad/deck/out/slides/slide-07.png">    </p:cNvPr>
+          <p:cNvPr id="2" name="Image 0">    </p:cNvPr>
           <p:cNvPicPr>
             <a:picLocks noChangeAspect="1"/>
           </p:cNvPicPr>
@@ -3463,7 +3463,7 @@
       </p:grpSpPr>
       <p:pic>
         <p:nvPicPr>
-          <p:cNvPr id="2" name="Image 0" descr="/private/tmp/claude-501/-Users-mushfiqurrahman-Library-Application-Support-Claude-scratch-workspaces-65a65a84-ad6b-4d3a-88a0-2621358d7689-499be8aa-3403-4123-8eac-18d254b7aa0a-scratch-2026-09-13-7b3d38/ef9f7b88-fe32-4abb-840c-9986bd52b9c4/scratchpad/deck/out/slides/slide-08.png">    </p:cNvPr>
+          <p:cNvPr id="2" name="Image 0">    </p:cNvPr>
           <p:cNvPicPr>
             <a:picLocks noChangeAspect="1"/>
           </p:cNvPicPr>
@@ -3512,7 +3512,7 @@
       </p:grpSpPr>
       <p:pic>
         <p:nvPicPr>
-          <p:cNvPr id="2" name="Image 0" descr="/private/tmp/claude-501/-Users-mushfiqurrahman-Library-Application-Support-Claude-scratch-workspaces-65a65a84-ad6b-4d3a-88a0-2621358d7689-499be8aa-3403-4123-8eac-18d254b7aa0a-scratch-2026-09-13-7b3d38/ef9f7b88-fe32-4abb-840c-9986bd52b9c4/scratchpad/deck/out/slides/slide-09.png">    </p:cNvPr>
+          <p:cNvPr id="2" name="Image 0">    </p:cNvPr>
           <p:cNvPicPr>
             <a:picLocks noChangeAspect="1"/>
           </p:cNvPicPr>

</xml_diff>